<commit_message>
Update bipolar stepper motor shield parts and notes.pptx
Add external wiring description
</commit_message>
<xml_diff>
--- a/og/layouts/motor_shield/bipolar stepper motor shield parts and notes.pptx
+++ b/og/layouts/motor_shield/bipolar stepper motor shield parts and notes.pptx
@@ -9,7 +9,7 @@
     <p:sldId id="318" r:id="rId6"/>
   </p:sldIdLst>
   <p:sldSz cx="12192000" cy="6858000"/>
-  <p:notesSz cx="6858000" cy="9144000"/>
+  <p:notesSz cx="7102475" cy="9388475"/>
   <p:defaultTextStyle>
     <a:defPPr>
       <a:defRPr lang="en-US"/>
@@ -2320,10 +2320,10 @@
       </p:sp>
       <p:grpSp>
         <p:nvGrpSpPr>
-          <p:cNvPr id="27" name="Group 26">
+          <p:cNvPr id="60" name="Group 59">
             <a:extLst>
               <a:ext uri="{FF2B5EF4-FFF2-40B4-BE49-F238E27FC236}">
-                <a16:creationId xmlns:a16="http://schemas.microsoft.com/office/drawing/2014/main" id="{F5489E52-0986-D672-5F68-3D45B427581F}"/>
+                <a16:creationId xmlns:a16="http://schemas.microsoft.com/office/drawing/2014/main" id="{BD934B61-FC7B-F236-60E7-7827EC7641C2}"/>
               </a:ext>
             </a:extLst>
           </p:cNvPr>
@@ -2332,54 +2332,175 @@
         </p:nvGrpSpPr>
         <p:grpSpPr>
           <a:xfrm>
-            <a:off x="1548030" y="1883818"/>
+            <a:off x="1708732" y="1883818"/>
             <a:ext cx="4720581" cy="3746995"/>
-            <a:chOff x="1548030" y="1883818"/>
+            <a:chOff x="1708732" y="1883818"/>
             <a:chExt cx="4720581" cy="3746995"/>
           </a:xfrm>
         </p:grpSpPr>
-        <p:pic>
-          <p:nvPicPr>
-            <p:cNvPr id="5" name="Picture 4">
+        <p:grpSp>
+          <p:nvGrpSpPr>
+            <p:cNvPr id="27" name="Group 26">
               <a:extLst>
                 <a:ext uri="{FF2B5EF4-FFF2-40B4-BE49-F238E27FC236}">
-                  <a16:creationId xmlns:a16="http://schemas.microsoft.com/office/drawing/2014/main" id="{F6B8D63D-E515-B97E-9350-F3BDA7B2B49A}"/>
+                  <a16:creationId xmlns:a16="http://schemas.microsoft.com/office/drawing/2014/main" id="{F5489E52-0986-D672-5F68-3D45B427581F}"/>
                 </a:ext>
               </a:extLst>
             </p:cNvPr>
-            <p:cNvPicPr>
-              <a:picLocks noChangeAspect="1"/>
-            </p:cNvPicPr>
+            <p:cNvGrpSpPr/>
             <p:nvPr/>
-          </p:nvPicPr>
-          <p:blipFill>
-            <a:blip r:embed="rId5">
-              <a:extLst>
-                <a:ext uri="{28A0092B-C50C-407E-A947-70E740481C1C}">
-                  <a14:useLocalDpi xmlns:a14="http://schemas.microsoft.com/office/drawing/2010/main" val="0"/>
-                </a:ext>
-              </a:extLst>
-            </a:blip>
-            <a:stretch>
-              <a:fillRect/>
-            </a:stretch>
-          </p:blipFill>
-          <p:spPr>
+          </p:nvGrpSpPr>
+          <p:grpSpPr>
             <a:xfrm>
-              <a:off x="1973707" y="1883818"/>
-              <a:ext cx="4294904" cy="3746995"/>
+              <a:off x="1708732" y="1883818"/>
+              <a:ext cx="4720581" cy="3746995"/>
+              <a:chOff x="1548030" y="1883818"/>
+              <a:chExt cx="4720581" cy="3746995"/>
             </a:xfrm>
-            <a:prstGeom prst="rect">
-              <a:avLst/>
-            </a:prstGeom>
-          </p:spPr>
-        </p:pic>
+          </p:grpSpPr>
+          <p:pic>
+            <p:nvPicPr>
+              <p:cNvPr id="5" name="Picture 4">
+                <a:extLst>
+                  <a:ext uri="{FF2B5EF4-FFF2-40B4-BE49-F238E27FC236}">
+                    <a16:creationId xmlns:a16="http://schemas.microsoft.com/office/drawing/2014/main" id="{F6B8D63D-E515-B97E-9350-F3BDA7B2B49A}"/>
+                  </a:ext>
+                </a:extLst>
+              </p:cNvPr>
+              <p:cNvPicPr>
+                <a:picLocks noChangeAspect="1"/>
+              </p:cNvPicPr>
+              <p:nvPr/>
+            </p:nvPicPr>
+            <p:blipFill>
+              <a:blip r:embed="rId5">
+                <a:extLst>
+                  <a:ext uri="{28A0092B-C50C-407E-A947-70E740481C1C}">
+                    <a14:useLocalDpi xmlns:a14="http://schemas.microsoft.com/office/drawing/2010/main" val="0"/>
+                  </a:ext>
+                </a:extLst>
+              </a:blip>
+              <a:stretch>
+                <a:fillRect/>
+              </a:stretch>
+            </p:blipFill>
+            <p:spPr>
+              <a:xfrm>
+                <a:off x="1973707" y="1883818"/>
+                <a:ext cx="4294904" cy="3746995"/>
+              </a:xfrm>
+              <a:prstGeom prst="rect">
+                <a:avLst/>
+              </a:prstGeom>
+            </p:spPr>
+          </p:pic>
+          <p:sp>
+            <p:nvSpPr>
+              <p:cNvPr id="23" name="TextBox 22">
+                <a:extLst>
+                  <a:ext uri="{FF2B5EF4-FFF2-40B4-BE49-F238E27FC236}">
+                    <a16:creationId xmlns:a16="http://schemas.microsoft.com/office/drawing/2014/main" id="{910DEFF4-941C-4B75-C9AB-AA6433F54B58}"/>
+                  </a:ext>
+                </a:extLst>
+              </p:cNvPr>
+              <p:cNvSpPr txBox="1"/>
+              <p:nvPr/>
+            </p:nvSpPr>
+            <p:spPr>
+              <a:xfrm>
+                <a:off x="1633549" y="3995528"/>
+                <a:ext cx="340158" cy="707886"/>
+              </a:xfrm>
+              <a:prstGeom prst="rect">
+                <a:avLst/>
+              </a:prstGeom>
+              <a:noFill/>
+            </p:spPr>
+            <p:txBody>
+              <a:bodyPr wrap="none" rtlCol="0">
+                <a:spAutoFit/>
+              </a:bodyPr>
+              <a:lstStyle/>
+              <a:p>
+                <a:r>
+                  <a:rPr lang="en-US" sz="1000" dirty="0"/>
+                  <a:t>1B</a:t>
+                </a:r>
+              </a:p>
+              <a:p>
+                <a:r>
+                  <a:rPr lang="en-US" sz="1000" dirty="0"/>
+                  <a:t>1A</a:t>
+                </a:r>
+              </a:p>
+              <a:p>
+                <a:r>
+                  <a:rPr lang="en-US" sz="1000" dirty="0"/>
+                  <a:t>2A</a:t>
+                </a:r>
+              </a:p>
+              <a:p>
+                <a:r>
+                  <a:rPr lang="en-US" sz="1000" dirty="0"/>
+                  <a:t>2B</a:t>
+                </a:r>
+              </a:p>
+            </p:txBody>
+          </p:sp>
+          <p:sp>
+            <p:nvSpPr>
+              <p:cNvPr id="26" name="TextBox 25">
+                <a:extLst>
+                  <a:ext uri="{FF2B5EF4-FFF2-40B4-BE49-F238E27FC236}">
+                    <a16:creationId xmlns:a16="http://schemas.microsoft.com/office/drawing/2014/main" id="{9B61236D-9702-71CC-1F75-615249CD7A1D}"/>
+                  </a:ext>
+                </a:extLst>
+              </p:cNvPr>
+              <p:cNvSpPr txBox="1"/>
+              <p:nvPr/>
+            </p:nvSpPr>
+            <p:spPr>
+              <a:xfrm>
+                <a:off x="1548030" y="3348782"/>
+                <a:ext cx="470000" cy="553998"/>
+              </a:xfrm>
+              <a:prstGeom prst="rect">
+                <a:avLst/>
+              </a:prstGeom>
+              <a:noFill/>
+            </p:spPr>
+            <p:txBody>
+              <a:bodyPr wrap="none" rtlCol="0">
+                <a:spAutoFit/>
+              </a:bodyPr>
+              <a:lstStyle/>
+              <a:p>
+                <a:r>
+                  <a:rPr lang="en-US" sz="1000" dirty="0"/>
+                  <a:t>NO</a:t>
+                </a:r>
+              </a:p>
+              <a:p>
+                <a:r>
+                  <a:rPr lang="en-US" sz="1000" dirty="0"/>
+                  <a:t>GND</a:t>
+                </a:r>
+              </a:p>
+              <a:p>
+                <a:r>
+                  <a:rPr lang="en-US" sz="1000" dirty="0"/>
+                  <a:t>NC</a:t>
+                </a:r>
+              </a:p>
+            </p:txBody>
+          </p:sp>
+        </p:grpSp>
         <p:sp>
           <p:nvSpPr>
-            <p:cNvPr id="23" name="TextBox 22">
+            <p:cNvPr id="43" name="TextBox 42">
               <a:extLst>
                 <a:ext uri="{FF2B5EF4-FFF2-40B4-BE49-F238E27FC236}">
-                  <a16:creationId xmlns:a16="http://schemas.microsoft.com/office/drawing/2014/main" id="{910DEFF4-941C-4B75-C9AB-AA6433F54B58}"/>
+                  <a16:creationId xmlns:a16="http://schemas.microsoft.com/office/drawing/2014/main" id="{A47CFCA4-F7D4-C9E0-4D00-9BB6B277B2C3}"/>
                 </a:ext>
               </a:extLst>
             </p:cNvPr>
@@ -2388,8 +2509,257 @@
           </p:nvSpPr>
           <p:spPr>
             <a:xfrm>
-              <a:off x="1633549" y="3995528"/>
-              <a:ext cx="340158" cy="707886"/>
+              <a:off x="1943732" y="3241185"/>
+              <a:ext cx="242374" cy="215444"/>
+            </a:xfrm>
+            <a:prstGeom prst="rect">
+              <a:avLst/>
+            </a:prstGeom>
+            <a:noFill/>
+          </p:spPr>
+          <p:txBody>
+            <a:bodyPr wrap="none" rtlCol="0">
+              <a:spAutoFit/>
+            </a:bodyPr>
+            <a:lstStyle/>
+            <a:p>
+              <a:r>
+                <a:rPr lang="en-US" sz="800" dirty="0"/>
+                <a:t>1</a:t>
+              </a:r>
+            </a:p>
+          </p:txBody>
+        </p:sp>
+        <p:sp>
+          <p:nvSpPr>
+            <p:cNvPr id="45" name="TextBox 44">
+              <a:extLst>
+                <a:ext uri="{FF2B5EF4-FFF2-40B4-BE49-F238E27FC236}">
+                  <a16:creationId xmlns:a16="http://schemas.microsoft.com/office/drawing/2014/main" id="{3B027FB6-71CD-A9FB-D93D-4E33769896CE}"/>
+                </a:ext>
+              </a:extLst>
+            </p:cNvPr>
+            <p:cNvSpPr txBox="1"/>
+            <p:nvPr/>
+          </p:nvSpPr>
+          <p:spPr>
+            <a:xfrm>
+              <a:off x="1943732" y="3887806"/>
+              <a:ext cx="242374" cy="215444"/>
+            </a:xfrm>
+            <a:prstGeom prst="rect">
+              <a:avLst/>
+            </a:prstGeom>
+            <a:noFill/>
+          </p:spPr>
+          <p:txBody>
+            <a:bodyPr wrap="none" rtlCol="0">
+              <a:spAutoFit/>
+            </a:bodyPr>
+            <a:lstStyle/>
+            <a:p>
+              <a:r>
+                <a:rPr lang="en-US" sz="800" dirty="0"/>
+                <a:t>1</a:t>
+              </a:r>
+            </a:p>
+          </p:txBody>
+        </p:sp>
+      </p:grpSp>
+      <p:grpSp>
+        <p:nvGrpSpPr>
+          <p:cNvPr id="61" name="Group 60">
+            <a:extLst>
+              <a:ext uri="{FF2B5EF4-FFF2-40B4-BE49-F238E27FC236}">
+                <a16:creationId xmlns:a16="http://schemas.microsoft.com/office/drawing/2014/main" id="{6BAE6C44-3C2E-0C79-55AD-B882F5D7D22B}"/>
+              </a:ext>
+            </a:extLst>
+          </p:cNvPr>
+          <p:cNvGrpSpPr/>
+          <p:nvPr/>
+        </p:nvGrpSpPr>
+        <p:grpSpPr>
+          <a:xfrm>
+            <a:off x="187059" y="3906881"/>
+            <a:ext cx="1607213" cy="1183633"/>
+            <a:chOff x="187059" y="3906881"/>
+            <a:chExt cx="1607213" cy="1183633"/>
+          </a:xfrm>
+        </p:grpSpPr>
+        <p:cxnSp>
+          <p:nvCxnSpPr>
+            <p:cNvPr id="6" name="Connector: Elbow 5">
+              <a:extLst>
+                <a:ext uri="{FF2B5EF4-FFF2-40B4-BE49-F238E27FC236}">
+                  <a16:creationId xmlns:a16="http://schemas.microsoft.com/office/drawing/2014/main" id="{154D0C18-F935-0FB4-E36D-8F89B1271B11}"/>
+                </a:ext>
+              </a:extLst>
+            </p:cNvPr>
+            <p:cNvCxnSpPr>
+              <a:cxnSpLocks/>
+            </p:cNvCxnSpPr>
+            <p:nvPr/>
+          </p:nvCxnSpPr>
+          <p:spPr>
+            <a:xfrm rot="10800000" flipV="1">
+              <a:off x="656001" y="4579620"/>
+              <a:ext cx="1138253" cy="197460"/>
+            </a:xfrm>
+            <a:prstGeom prst="bentConnector3">
+              <a:avLst/>
+            </a:prstGeom>
+          </p:spPr>
+          <p:style>
+            <a:lnRef idx="1">
+              <a:schemeClr val="accent1"/>
+            </a:lnRef>
+            <a:fillRef idx="0">
+              <a:schemeClr val="accent1"/>
+            </a:fillRef>
+            <a:effectRef idx="0">
+              <a:schemeClr val="accent1"/>
+            </a:effectRef>
+            <a:fontRef idx="minor">
+              <a:schemeClr val="tx1"/>
+            </a:fontRef>
+          </p:style>
+        </p:cxnSp>
+        <p:cxnSp>
+          <p:nvCxnSpPr>
+            <p:cNvPr id="8" name="Connector: Elbow 7">
+              <a:extLst>
+                <a:ext uri="{FF2B5EF4-FFF2-40B4-BE49-F238E27FC236}">
+                  <a16:creationId xmlns:a16="http://schemas.microsoft.com/office/drawing/2014/main" id="{69D0B917-9164-5DC1-3DC9-E06F7BF8C383}"/>
+                </a:ext>
+              </a:extLst>
+            </p:cNvPr>
+            <p:cNvCxnSpPr>
+              <a:cxnSpLocks/>
+            </p:cNvCxnSpPr>
+            <p:nvPr/>
+          </p:nvCxnSpPr>
+          <p:spPr>
+            <a:xfrm rot="10800000" flipV="1">
+              <a:off x="648383" y="4414713"/>
+              <a:ext cx="1142070" cy="68539"/>
+            </a:xfrm>
+            <a:prstGeom prst="bentConnector3">
+              <a:avLst>
+                <a:gd name="adj1" fmla="val 59341"/>
+              </a:avLst>
+            </a:prstGeom>
+          </p:spPr>
+          <p:style>
+            <a:lnRef idx="1">
+              <a:schemeClr val="accent1"/>
+            </a:lnRef>
+            <a:fillRef idx="0">
+              <a:schemeClr val="accent1"/>
+            </a:fillRef>
+            <a:effectRef idx="0">
+              <a:schemeClr val="accent1"/>
+            </a:effectRef>
+            <a:fontRef idx="minor">
+              <a:schemeClr val="tx1"/>
+            </a:fontRef>
+          </p:style>
+        </p:cxnSp>
+        <p:cxnSp>
+          <p:nvCxnSpPr>
+            <p:cNvPr id="15" name="Connector: Elbow 14">
+              <a:extLst>
+                <a:ext uri="{FF2B5EF4-FFF2-40B4-BE49-F238E27FC236}">
+                  <a16:creationId xmlns:a16="http://schemas.microsoft.com/office/drawing/2014/main" id="{FC2014BE-B94D-2D35-0384-EAFAF0485EC0}"/>
+                </a:ext>
+              </a:extLst>
+            </p:cNvPr>
+            <p:cNvCxnSpPr>
+              <a:cxnSpLocks/>
+            </p:cNvCxnSpPr>
+            <p:nvPr/>
+          </p:nvCxnSpPr>
+          <p:spPr>
+            <a:xfrm rot="10800000" flipV="1">
+              <a:off x="648384" y="3940170"/>
+              <a:ext cx="571035" cy="376715"/>
+            </a:xfrm>
+            <a:prstGeom prst="bentConnector3">
+              <a:avLst>
+                <a:gd name="adj1" fmla="val 50000"/>
+              </a:avLst>
+            </a:prstGeom>
+          </p:spPr>
+          <p:style>
+            <a:lnRef idx="1">
+              <a:schemeClr val="accent1"/>
+            </a:lnRef>
+            <a:fillRef idx="0">
+              <a:schemeClr val="accent1"/>
+            </a:fillRef>
+            <a:effectRef idx="0">
+              <a:schemeClr val="accent1"/>
+            </a:effectRef>
+            <a:fontRef idx="minor">
+              <a:schemeClr val="tx1"/>
+            </a:fontRef>
+          </p:style>
+        </p:cxnSp>
+        <p:cxnSp>
+          <p:nvCxnSpPr>
+            <p:cNvPr id="18" name="Connector: Elbow 17">
+              <a:extLst>
+                <a:ext uri="{FF2B5EF4-FFF2-40B4-BE49-F238E27FC236}">
+                  <a16:creationId xmlns:a16="http://schemas.microsoft.com/office/drawing/2014/main" id="{1A7FDAC4-9710-294B-D703-2430C03E72A8}"/>
+                </a:ext>
+              </a:extLst>
+            </p:cNvPr>
+            <p:cNvCxnSpPr>
+              <a:cxnSpLocks/>
+            </p:cNvCxnSpPr>
+            <p:nvPr/>
+          </p:nvCxnSpPr>
+          <p:spPr>
+            <a:xfrm rot="10800000">
+              <a:off x="652192" y="4036539"/>
+              <a:ext cx="1142080" cy="220000"/>
+            </a:xfrm>
+            <a:prstGeom prst="bentConnector3">
+              <a:avLst>
+                <a:gd name="adj1" fmla="val 59341"/>
+              </a:avLst>
+            </a:prstGeom>
+          </p:spPr>
+          <p:style>
+            <a:lnRef idx="1">
+              <a:schemeClr val="accent1"/>
+            </a:lnRef>
+            <a:fillRef idx="0">
+              <a:schemeClr val="accent1"/>
+            </a:fillRef>
+            <a:effectRef idx="0">
+              <a:schemeClr val="accent1"/>
+            </a:effectRef>
+            <a:fontRef idx="minor">
+              <a:schemeClr val="tx1"/>
+            </a:fontRef>
+          </p:style>
+        </p:cxnSp>
+        <p:sp>
+          <p:nvSpPr>
+            <p:cNvPr id="32" name="TextBox 31">
+              <a:extLst>
+                <a:ext uri="{FF2B5EF4-FFF2-40B4-BE49-F238E27FC236}">
+                  <a16:creationId xmlns:a16="http://schemas.microsoft.com/office/drawing/2014/main" id="{8FE7B05A-F70D-5152-84EB-960F6A7AA021}"/>
+                </a:ext>
+              </a:extLst>
+            </p:cNvPr>
+            <p:cNvSpPr txBox="1"/>
+            <p:nvPr/>
+          </p:nvSpPr>
+          <p:spPr>
+            <a:xfrm>
+              <a:off x="312044" y="3906881"/>
+              <a:ext cx="340158" cy="1015663"/>
             </a:xfrm>
             <a:prstGeom prst="rect">
               <a:avLst/>
@@ -2404,13 +2774,13 @@
             <a:p>
               <a:r>
                 <a:rPr lang="en-US" sz="1000" dirty="0"/>
-                <a:t>1B</a:t>
+                <a:t>1A</a:t>
               </a:r>
             </a:p>
             <a:p>
               <a:r>
                 <a:rPr lang="en-US" sz="1000" dirty="0"/>
-                <a:t>1A</a:t>
+                <a:t>-</a:t>
               </a:r>
             </a:p>
             <a:p>
@@ -2422,17 +2792,69 @@
             <a:p>
               <a:r>
                 <a:rPr lang="en-US" sz="1000" dirty="0"/>
+                <a:t>1B</a:t>
+              </a:r>
+            </a:p>
+            <a:p>
+              <a:r>
+                <a:rPr lang="en-US" sz="1000" dirty="0"/>
+                <a:t>-</a:t>
+              </a:r>
+            </a:p>
+            <a:p>
+              <a:r>
+                <a:rPr lang="en-US" sz="1000" dirty="0"/>
                 <a:t>2B</a:t>
               </a:r>
             </a:p>
           </p:txBody>
         </p:sp>
+        <p:cxnSp>
+          <p:nvCxnSpPr>
+            <p:cNvPr id="39" name="Connector: Elbow 38">
+              <a:extLst>
+                <a:ext uri="{FF2B5EF4-FFF2-40B4-BE49-F238E27FC236}">
+                  <a16:creationId xmlns:a16="http://schemas.microsoft.com/office/drawing/2014/main" id="{0FE5784E-1AD7-F226-7CD9-2B97461E8C4F}"/>
+                </a:ext>
+              </a:extLst>
+            </p:cNvPr>
+            <p:cNvCxnSpPr>
+              <a:cxnSpLocks/>
+            </p:cNvCxnSpPr>
+            <p:nvPr/>
+          </p:nvCxnSpPr>
+          <p:spPr>
+            <a:xfrm rot="10800000">
+              <a:off x="1182863" y="3940171"/>
+              <a:ext cx="607590" cy="182984"/>
+            </a:xfrm>
+            <a:prstGeom prst="bentConnector3">
+              <a:avLst>
+                <a:gd name="adj1" fmla="val 91386"/>
+              </a:avLst>
+            </a:prstGeom>
+          </p:spPr>
+          <p:style>
+            <a:lnRef idx="1">
+              <a:schemeClr val="accent1"/>
+            </a:lnRef>
+            <a:fillRef idx="0">
+              <a:schemeClr val="accent1"/>
+            </a:fillRef>
+            <a:effectRef idx="0">
+              <a:schemeClr val="accent1"/>
+            </a:effectRef>
+            <a:fontRef idx="minor">
+              <a:schemeClr val="tx1"/>
+            </a:fontRef>
+          </p:style>
+        </p:cxnSp>
         <p:sp>
           <p:nvSpPr>
-            <p:cNvPr id="26" name="TextBox 25">
+            <p:cNvPr id="47" name="TextBox 46">
               <a:extLst>
                 <a:ext uri="{FF2B5EF4-FFF2-40B4-BE49-F238E27FC236}">
-                  <a16:creationId xmlns:a16="http://schemas.microsoft.com/office/drawing/2014/main" id="{9B61236D-9702-71CC-1F75-615249CD7A1D}"/>
+                  <a16:creationId xmlns:a16="http://schemas.microsoft.com/office/drawing/2014/main" id="{5F95F153-3438-60B2-2576-3BEFDFA7F297}"/>
                 </a:ext>
               </a:extLst>
             </p:cNvPr>
@@ -2441,8 +2863,8 @@
           </p:nvSpPr>
           <p:spPr>
             <a:xfrm>
-              <a:off x="1548030" y="3348782"/>
-              <a:ext cx="470000" cy="553998"/>
+              <a:off x="187059" y="4875070"/>
+              <a:ext cx="242374" cy="215444"/>
             </a:xfrm>
             <a:prstGeom prst="rect">
               <a:avLst/>
@@ -2456,25 +2878,677 @@
             <a:lstStyle/>
             <a:p>
               <a:r>
-                <a:rPr lang="en-US" sz="1000" dirty="0"/>
-                <a:t>NO</a:t>
-              </a:r>
-            </a:p>
-            <a:p>
-              <a:r>
-                <a:rPr lang="en-US" sz="1000" dirty="0"/>
-                <a:t>GND</a:t>
-              </a:r>
-            </a:p>
-            <a:p>
-              <a:r>
-                <a:rPr lang="en-US" sz="1000" dirty="0"/>
-                <a:t>NC</a:t>
+                <a:rPr lang="en-US" sz="800" dirty="0"/>
+                <a:t>1</a:t>
               </a:r>
             </a:p>
           </p:txBody>
         </p:sp>
+        <p:sp>
+          <p:nvSpPr>
+            <p:cNvPr id="48" name="Rectangle 47">
+              <a:extLst>
+                <a:ext uri="{FF2B5EF4-FFF2-40B4-BE49-F238E27FC236}">
+                  <a16:creationId xmlns:a16="http://schemas.microsoft.com/office/drawing/2014/main" id="{BA44106B-8A1A-0D94-7DF4-D8A3DD95827C}"/>
+                </a:ext>
+              </a:extLst>
+            </p:cNvPr>
+            <p:cNvSpPr/>
+            <p:nvPr/>
+          </p:nvSpPr>
+          <p:spPr>
+            <a:xfrm>
+              <a:off x="222657" y="3971143"/>
+              <a:ext cx="113187" cy="113187"/>
+            </a:xfrm>
+            <a:prstGeom prst="rect">
+              <a:avLst/>
+            </a:prstGeom>
+            <a:solidFill>
+              <a:schemeClr val="bg1"/>
+            </a:solidFill>
+            <a:ln w="12700">
+              <a:solidFill>
+                <a:schemeClr val="tx1"/>
+              </a:solidFill>
+            </a:ln>
+          </p:spPr>
+          <p:style>
+            <a:lnRef idx="2">
+              <a:schemeClr val="accent1">
+                <a:shade val="15000"/>
+              </a:schemeClr>
+            </a:lnRef>
+            <a:fillRef idx="1">
+              <a:schemeClr val="accent1"/>
+            </a:fillRef>
+            <a:effectRef idx="0">
+              <a:schemeClr val="accent1"/>
+            </a:effectRef>
+            <a:fontRef idx="minor">
+              <a:schemeClr val="lt1"/>
+            </a:fontRef>
+          </p:style>
+          <p:txBody>
+            <a:bodyPr rtlCol="0" anchor="ctr"/>
+            <a:lstStyle/>
+            <a:p>
+              <a:pPr algn="ctr"/>
+              <a:endParaRPr lang="en-US"/>
+            </a:p>
+          </p:txBody>
+        </p:sp>
+        <p:sp>
+          <p:nvSpPr>
+            <p:cNvPr id="50" name="Rectangle 49">
+              <a:extLst>
+                <a:ext uri="{FF2B5EF4-FFF2-40B4-BE49-F238E27FC236}">
+                  <a16:creationId xmlns:a16="http://schemas.microsoft.com/office/drawing/2014/main" id="{5D953DE2-B1D8-EE06-BECD-2E210E094AA4}"/>
+                </a:ext>
+              </a:extLst>
+            </p:cNvPr>
+            <p:cNvSpPr/>
+            <p:nvPr/>
+          </p:nvSpPr>
+          <p:spPr>
+            <a:xfrm>
+              <a:off x="222657" y="4123538"/>
+              <a:ext cx="113187" cy="113187"/>
+            </a:xfrm>
+            <a:prstGeom prst="rect">
+              <a:avLst/>
+            </a:prstGeom>
+            <a:solidFill>
+              <a:schemeClr val="bg1"/>
+            </a:solidFill>
+            <a:ln w="12700">
+              <a:solidFill>
+                <a:schemeClr val="tx1"/>
+              </a:solidFill>
+            </a:ln>
+          </p:spPr>
+          <p:style>
+            <a:lnRef idx="2">
+              <a:schemeClr val="accent1">
+                <a:shade val="15000"/>
+              </a:schemeClr>
+            </a:lnRef>
+            <a:fillRef idx="1">
+              <a:schemeClr val="accent1"/>
+            </a:fillRef>
+            <a:effectRef idx="0">
+              <a:schemeClr val="accent1"/>
+            </a:effectRef>
+            <a:fontRef idx="minor">
+              <a:schemeClr val="lt1"/>
+            </a:fontRef>
+          </p:style>
+          <p:txBody>
+            <a:bodyPr rtlCol="0" anchor="ctr"/>
+            <a:lstStyle/>
+            <a:p>
+              <a:pPr algn="ctr"/>
+              <a:endParaRPr lang="en-US"/>
+            </a:p>
+          </p:txBody>
+        </p:sp>
+        <p:sp>
+          <p:nvSpPr>
+            <p:cNvPr id="52" name="Rectangle 51">
+              <a:extLst>
+                <a:ext uri="{FF2B5EF4-FFF2-40B4-BE49-F238E27FC236}">
+                  <a16:creationId xmlns:a16="http://schemas.microsoft.com/office/drawing/2014/main" id="{220CCBEA-4CBA-08DF-BC03-FABB27136F2D}"/>
+                </a:ext>
+              </a:extLst>
+            </p:cNvPr>
+            <p:cNvSpPr/>
+            <p:nvPr/>
+          </p:nvSpPr>
+          <p:spPr>
+            <a:xfrm>
+              <a:off x="222657" y="4275933"/>
+              <a:ext cx="113187" cy="113187"/>
+            </a:xfrm>
+            <a:prstGeom prst="rect">
+              <a:avLst/>
+            </a:prstGeom>
+            <a:solidFill>
+              <a:schemeClr val="bg1"/>
+            </a:solidFill>
+            <a:ln w="12700">
+              <a:solidFill>
+                <a:schemeClr val="tx1"/>
+              </a:solidFill>
+            </a:ln>
+          </p:spPr>
+          <p:style>
+            <a:lnRef idx="2">
+              <a:schemeClr val="accent1">
+                <a:shade val="15000"/>
+              </a:schemeClr>
+            </a:lnRef>
+            <a:fillRef idx="1">
+              <a:schemeClr val="accent1"/>
+            </a:fillRef>
+            <a:effectRef idx="0">
+              <a:schemeClr val="accent1"/>
+            </a:effectRef>
+            <a:fontRef idx="minor">
+              <a:schemeClr val="lt1"/>
+            </a:fontRef>
+          </p:style>
+          <p:txBody>
+            <a:bodyPr rtlCol="0" anchor="ctr"/>
+            <a:lstStyle/>
+            <a:p>
+              <a:pPr algn="ctr"/>
+              <a:endParaRPr lang="en-US"/>
+            </a:p>
+          </p:txBody>
+        </p:sp>
+        <p:sp>
+          <p:nvSpPr>
+            <p:cNvPr id="54" name="Rectangle 53">
+              <a:extLst>
+                <a:ext uri="{FF2B5EF4-FFF2-40B4-BE49-F238E27FC236}">
+                  <a16:creationId xmlns:a16="http://schemas.microsoft.com/office/drawing/2014/main" id="{32CCAD79-DB97-292B-6AAB-B8D485482DF6}"/>
+                </a:ext>
+              </a:extLst>
+            </p:cNvPr>
+            <p:cNvSpPr/>
+            <p:nvPr/>
+          </p:nvSpPr>
+          <p:spPr>
+            <a:xfrm>
+              <a:off x="222657" y="4428328"/>
+              <a:ext cx="113187" cy="113187"/>
+            </a:xfrm>
+            <a:prstGeom prst="rect">
+              <a:avLst/>
+            </a:prstGeom>
+            <a:solidFill>
+              <a:schemeClr val="bg1"/>
+            </a:solidFill>
+            <a:ln w="12700">
+              <a:solidFill>
+                <a:schemeClr val="tx1"/>
+              </a:solidFill>
+            </a:ln>
+          </p:spPr>
+          <p:style>
+            <a:lnRef idx="2">
+              <a:schemeClr val="accent1">
+                <a:shade val="15000"/>
+              </a:schemeClr>
+            </a:lnRef>
+            <a:fillRef idx="1">
+              <a:schemeClr val="accent1"/>
+            </a:fillRef>
+            <a:effectRef idx="0">
+              <a:schemeClr val="accent1"/>
+            </a:effectRef>
+            <a:fontRef idx="minor">
+              <a:schemeClr val="lt1"/>
+            </a:fontRef>
+          </p:style>
+          <p:txBody>
+            <a:bodyPr rtlCol="0" anchor="ctr"/>
+            <a:lstStyle/>
+            <a:p>
+              <a:pPr algn="ctr"/>
+              <a:endParaRPr lang="en-US" b="1" dirty="0"/>
+            </a:p>
+          </p:txBody>
+        </p:sp>
+        <p:sp>
+          <p:nvSpPr>
+            <p:cNvPr id="56" name="Rectangle 55">
+              <a:extLst>
+                <a:ext uri="{FF2B5EF4-FFF2-40B4-BE49-F238E27FC236}">
+                  <a16:creationId xmlns:a16="http://schemas.microsoft.com/office/drawing/2014/main" id="{DD286A76-C743-EE3F-37A1-CD3D2DA59305}"/>
+                </a:ext>
+              </a:extLst>
+            </p:cNvPr>
+            <p:cNvSpPr/>
+            <p:nvPr/>
+          </p:nvSpPr>
+          <p:spPr>
+            <a:xfrm>
+              <a:off x="222657" y="4580723"/>
+              <a:ext cx="113187" cy="113187"/>
+            </a:xfrm>
+            <a:prstGeom prst="rect">
+              <a:avLst/>
+            </a:prstGeom>
+            <a:solidFill>
+              <a:schemeClr val="bg1"/>
+            </a:solidFill>
+            <a:ln w="12700">
+              <a:solidFill>
+                <a:schemeClr val="tx1"/>
+              </a:solidFill>
+            </a:ln>
+          </p:spPr>
+          <p:style>
+            <a:lnRef idx="2">
+              <a:schemeClr val="accent1">
+                <a:shade val="15000"/>
+              </a:schemeClr>
+            </a:lnRef>
+            <a:fillRef idx="1">
+              <a:schemeClr val="accent1"/>
+            </a:fillRef>
+            <a:effectRef idx="0">
+              <a:schemeClr val="accent1"/>
+            </a:effectRef>
+            <a:fontRef idx="minor">
+              <a:schemeClr val="lt1"/>
+            </a:fontRef>
+          </p:style>
+          <p:txBody>
+            <a:bodyPr rtlCol="0" anchor="ctr"/>
+            <a:lstStyle/>
+            <a:p>
+              <a:pPr algn="ctr"/>
+              <a:endParaRPr lang="en-US"/>
+            </a:p>
+          </p:txBody>
+        </p:sp>
+        <p:sp>
+          <p:nvSpPr>
+            <p:cNvPr id="58" name="Rectangle 57">
+              <a:extLst>
+                <a:ext uri="{FF2B5EF4-FFF2-40B4-BE49-F238E27FC236}">
+                  <a16:creationId xmlns:a16="http://schemas.microsoft.com/office/drawing/2014/main" id="{DF8F2C95-F4DF-6F47-6513-4C07D58C6B11}"/>
+                </a:ext>
+              </a:extLst>
+            </p:cNvPr>
+            <p:cNvSpPr/>
+            <p:nvPr/>
+          </p:nvSpPr>
+          <p:spPr>
+            <a:xfrm>
+              <a:off x="222657" y="4733119"/>
+              <a:ext cx="113187" cy="113187"/>
+            </a:xfrm>
+            <a:prstGeom prst="rect">
+              <a:avLst/>
+            </a:prstGeom>
+            <a:solidFill>
+              <a:schemeClr val="bg1"/>
+            </a:solidFill>
+            <a:ln w="12700">
+              <a:solidFill>
+                <a:schemeClr val="tx1"/>
+              </a:solidFill>
+            </a:ln>
+          </p:spPr>
+          <p:style>
+            <a:lnRef idx="2">
+              <a:schemeClr val="accent1">
+                <a:shade val="15000"/>
+              </a:schemeClr>
+            </a:lnRef>
+            <a:fillRef idx="1">
+              <a:schemeClr val="accent1"/>
+            </a:fillRef>
+            <a:effectRef idx="0">
+              <a:schemeClr val="accent1"/>
+            </a:effectRef>
+            <a:fontRef idx="minor">
+              <a:schemeClr val="lt1"/>
+            </a:fontRef>
+          </p:style>
+          <p:txBody>
+            <a:bodyPr rtlCol="0" anchor="ctr"/>
+            <a:lstStyle/>
+            <a:p>
+              <a:pPr algn="ctr"/>
+              <a:endParaRPr lang="en-US"/>
+            </a:p>
+          </p:txBody>
+        </p:sp>
       </p:grpSp>
+      <p:sp>
+        <p:nvSpPr>
+          <p:cNvPr id="62" name="TextBox 61">
+            <a:extLst>
+              <a:ext uri="{FF2B5EF4-FFF2-40B4-BE49-F238E27FC236}">
+                <a16:creationId xmlns:a16="http://schemas.microsoft.com/office/drawing/2014/main" id="{56ABD6FA-497B-A021-36F8-9FCCC0CBD207}"/>
+              </a:ext>
+            </a:extLst>
+          </p:cNvPr>
+          <p:cNvSpPr txBox="1"/>
+          <p:nvPr/>
+        </p:nvSpPr>
+        <p:spPr>
+          <a:xfrm>
+            <a:off x="114149" y="3563381"/>
+            <a:ext cx="1066318" cy="246221"/>
+          </a:xfrm>
+          <a:prstGeom prst="rect">
+            <a:avLst/>
+          </a:prstGeom>
+          <a:noFill/>
+        </p:spPr>
+        <p:txBody>
+          <a:bodyPr wrap="none" rtlCol="0">
+            <a:spAutoFit/>
+          </a:bodyPr>
+          <a:lstStyle/>
+          <a:p>
+            <a:r>
+              <a:rPr lang="en-US" sz="1000" dirty="0">
+                <a:latin typeface="+mj-lt"/>
+              </a:rPr>
+              <a:t>Motor terminals</a:t>
+            </a:r>
+          </a:p>
+        </p:txBody>
+      </p:sp>
+      <p:pic>
+        <p:nvPicPr>
+          <p:cNvPr id="63" name="Picture 62" descr="NEMA17 Wiring Overview">
+            <a:extLst>
+              <a:ext uri="{FF2B5EF4-FFF2-40B4-BE49-F238E27FC236}">
+                <a16:creationId xmlns:a16="http://schemas.microsoft.com/office/drawing/2014/main" id="{EB2A49A5-E2FF-978F-88E3-C34E0171389C}"/>
+              </a:ext>
+            </a:extLst>
+          </p:cNvPr>
+          <p:cNvPicPr>
+            <a:picLocks noChangeAspect="1"/>
+          </p:cNvPicPr>
+          <p:nvPr/>
+        </p:nvPicPr>
+        <p:blipFill>
+          <a:blip r:embed="rId6"/>
+          <a:srcRect l="13441" r="53701" b="21837"/>
+          <a:stretch>
+            <a:fillRect/>
+          </a:stretch>
+        </p:blipFill>
+        <p:spPr>
+          <a:xfrm>
+            <a:off x="222657" y="2502190"/>
+            <a:ext cx="592543" cy="767456"/>
+          </a:xfrm>
+          <a:prstGeom prst="rect">
+            <a:avLst/>
+          </a:prstGeom>
+        </p:spPr>
+      </p:pic>
+      <p:pic>
+        <p:nvPicPr>
+          <p:cNvPr id="65" name="Picture 64" descr="NEMA17 Wiring Overview">
+            <a:extLst>
+              <a:ext uri="{FF2B5EF4-FFF2-40B4-BE49-F238E27FC236}">
+                <a16:creationId xmlns:a16="http://schemas.microsoft.com/office/drawing/2014/main" id="{57E73F69-AEE5-B1C0-2E25-052A8F1697CD}"/>
+              </a:ext>
+            </a:extLst>
+          </p:cNvPr>
+          <p:cNvPicPr>
+            <a:picLocks noChangeAspect="1"/>
+          </p:cNvPicPr>
+          <p:nvPr/>
+        </p:nvPicPr>
+        <p:blipFill>
+          <a:blip r:embed="rId6"/>
+          <a:srcRect l="67141" b="21837"/>
+          <a:stretch>
+            <a:fillRect/>
+          </a:stretch>
+        </p:blipFill>
+        <p:spPr>
+          <a:xfrm>
+            <a:off x="973691" y="2502188"/>
+            <a:ext cx="592543" cy="767456"/>
+          </a:xfrm>
+          <a:prstGeom prst="rect">
+            <a:avLst/>
+          </a:prstGeom>
+        </p:spPr>
+      </p:pic>
+      <p:sp>
+        <p:nvSpPr>
+          <p:cNvPr id="66" name="TextBox 65">
+            <a:extLst>
+              <a:ext uri="{FF2B5EF4-FFF2-40B4-BE49-F238E27FC236}">
+                <a16:creationId xmlns:a16="http://schemas.microsoft.com/office/drawing/2014/main" id="{2691D143-2CB0-B13D-2638-485E999EF891}"/>
+              </a:ext>
+            </a:extLst>
+          </p:cNvPr>
+          <p:cNvSpPr txBox="1"/>
+          <p:nvPr/>
+        </p:nvSpPr>
+        <p:spPr>
+          <a:xfrm>
+            <a:off x="114149" y="1670901"/>
+            <a:ext cx="1956698" cy="707886"/>
+          </a:xfrm>
+          <a:prstGeom prst="rect">
+            <a:avLst/>
+          </a:prstGeom>
+          <a:noFill/>
+        </p:spPr>
+        <p:txBody>
+          <a:bodyPr wrap="square" rtlCol="0">
+            <a:spAutoFit/>
+          </a:bodyPr>
+          <a:lstStyle/>
+          <a:p>
+            <a:r>
+              <a:rPr lang="en-US" sz="1000" dirty="0"/>
+              <a:t>NEMA-17 bipolar stepper </a:t>
+            </a:r>
+            <a:br>
+              <a:rPr lang="en-US" sz="1000" dirty="0"/>
+            </a:br>
+            <a:r>
+              <a:rPr lang="en-US" sz="1000" dirty="0"/>
+              <a:t>wiring: but Reddit says “there is no standard configuration for stepper motor terminals”</a:t>
+            </a:r>
+          </a:p>
+        </p:txBody>
+      </p:sp>
+      <p:sp>
+        <p:nvSpPr>
+          <p:cNvPr id="68" name="TextBox 67">
+            <a:extLst>
+              <a:ext uri="{FF2B5EF4-FFF2-40B4-BE49-F238E27FC236}">
+                <a16:creationId xmlns:a16="http://schemas.microsoft.com/office/drawing/2014/main" id="{E442654B-1650-1A4D-B20E-7B7E61DB33D3}"/>
+              </a:ext>
+            </a:extLst>
+          </p:cNvPr>
+          <p:cNvSpPr txBox="1"/>
+          <p:nvPr/>
+        </p:nvSpPr>
+        <p:spPr>
+          <a:xfrm>
+            <a:off x="1001686" y="3232825"/>
+            <a:ext cx="846707" cy="400110"/>
+          </a:xfrm>
+          <a:prstGeom prst="rect">
+            <a:avLst/>
+          </a:prstGeom>
+          <a:noFill/>
+        </p:spPr>
+        <p:txBody>
+          <a:bodyPr wrap="none" rtlCol="0">
+            <a:spAutoFit/>
+          </a:bodyPr>
+          <a:lstStyle/>
+          <a:p>
+            <a:r>
+              <a:rPr lang="en-US" sz="1000" dirty="0">
+                <a:latin typeface="+mj-lt"/>
+              </a:rPr>
+              <a:t>Limit switch</a:t>
+            </a:r>
+          </a:p>
+          <a:p>
+            <a:r>
+              <a:rPr lang="en-US" sz="1000" dirty="0">
+                <a:latin typeface="+mj-lt"/>
+              </a:rPr>
+              <a:t>jack</a:t>
+            </a:r>
+          </a:p>
+        </p:txBody>
+      </p:sp>
+      <p:sp>
+        <p:nvSpPr>
+          <p:cNvPr id="70" name="TextBox 69">
+            <a:extLst>
+              <a:ext uri="{FF2B5EF4-FFF2-40B4-BE49-F238E27FC236}">
+                <a16:creationId xmlns:a16="http://schemas.microsoft.com/office/drawing/2014/main" id="{2A128FA6-FBE0-04E7-AE53-4CC7ADA4F336}"/>
+              </a:ext>
+            </a:extLst>
+          </p:cNvPr>
+          <p:cNvSpPr txBox="1"/>
+          <p:nvPr/>
+        </p:nvSpPr>
+        <p:spPr>
+          <a:xfrm>
+            <a:off x="1001686" y="4815099"/>
+            <a:ext cx="774571" cy="246221"/>
+          </a:xfrm>
+          <a:prstGeom prst="rect">
+            <a:avLst/>
+          </a:prstGeom>
+          <a:noFill/>
+        </p:spPr>
+        <p:txBody>
+          <a:bodyPr wrap="none" rtlCol="0">
+            <a:spAutoFit/>
+          </a:bodyPr>
+          <a:lstStyle/>
+          <a:p>
+            <a:r>
+              <a:rPr lang="en-US" sz="1000" dirty="0">
+                <a:latin typeface="+mj-lt"/>
+              </a:rPr>
+              <a:t>Motor jack</a:t>
+            </a:r>
+          </a:p>
+        </p:txBody>
+      </p:sp>
+      <p:cxnSp>
+        <p:nvCxnSpPr>
+          <p:cNvPr id="72" name="Straight Arrow Connector 71">
+            <a:extLst>
+              <a:ext uri="{FF2B5EF4-FFF2-40B4-BE49-F238E27FC236}">
+                <a16:creationId xmlns:a16="http://schemas.microsoft.com/office/drawing/2014/main" id="{E21F2A6A-0F36-B3B8-F2F7-57048E17AB50}"/>
+              </a:ext>
+            </a:extLst>
+          </p:cNvPr>
+          <p:cNvCxnSpPr>
+            <a:cxnSpLocks/>
+          </p:cNvCxnSpPr>
+          <p:nvPr/>
+        </p:nvCxnSpPr>
+        <p:spPr>
+          <a:xfrm flipH="1">
+            <a:off x="5136776" y="1540034"/>
+            <a:ext cx="3048000" cy="1729610"/>
+          </a:xfrm>
+          <a:prstGeom prst="straightConnector1">
+            <a:avLst/>
+          </a:prstGeom>
+          <a:ln w="38100">
+            <a:tailEnd type="triangle"/>
+          </a:ln>
+        </p:spPr>
+        <p:style>
+          <a:lnRef idx="1">
+            <a:schemeClr val="accent6"/>
+          </a:lnRef>
+          <a:fillRef idx="0">
+            <a:schemeClr val="accent6"/>
+          </a:fillRef>
+          <a:effectRef idx="0">
+            <a:schemeClr val="accent6"/>
+          </a:effectRef>
+          <a:fontRef idx="minor">
+            <a:schemeClr val="tx1"/>
+          </a:fontRef>
+        </p:style>
+      </p:cxnSp>
+      <p:cxnSp>
+        <p:nvCxnSpPr>
+          <p:cNvPr id="74" name="Straight Arrow Connector 73">
+            <a:extLst>
+              <a:ext uri="{FF2B5EF4-FFF2-40B4-BE49-F238E27FC236}">
+                <a16:creationId xmlns:a16="http://schemas.microsoft.com/office/drawing/2014/main" id="{34AE37D2-997E-D093-EAEB-38DC5210211A}"/>
+              </a:ext>
+            </a:extLst>
+          </p:cNvPr>
+          <p:cNvCxnSpPr>
+            <a:cxnSpLocks/>
+          </p:cNvCxnSpPr>
+          <p:nvPr/>
+        </p:nvCxnSpPr>
+        <p:spPr>
+          <a:xfrm>
+            <a:off x="10443882" y="1697273"/>
+            <a:ext cx="573742" cy="1099715"/>
+          </a:xfrm>
+          <a:prstGeom prst="straightConnector1">
+            <a:avLst/>
+          </a:prstGeom>
+          <a:ln w="38100">
+            <a:tailEnd type="triangle"/>
+          </a:ln>
+        </p:spPr>
+        <p:style>
+          <a:lnRef idx="1">
+            <a:schemeClr val="accent6"/>
+          </a:lnRef>
+          <a:fillRef idx="0">
+            <a:schemeClr val="accent6"/>
+          </a:fillRef>
+          <a:effectRef idx="0">
+            <a:schemeClr val="accent6"/>
+          </a:effectRef>
+          <a:fontRef idx="minor">
+            <a:schemeClr val="tx1"/>
+          </a:fontRef>
+        </p:style>
+      </p:cxnSp>
+      <p:sp>
+        <p:nvSpPr>
+          <p:cNvPr id="76" name="TextBox 75">
+            <a:extLst>
+              <a:ext uri="{FF2B5EF4-FFF2-40B4-BE49-F238E27FC236}">
+                <a16:creationId xmlns:a16="http://schemas.microsoft.com/office/drawing/2014/main" id="{4439C6E1-7BE7-D736-2A97-10631FAC4F78}"/>
+              </a:ext>
+            </a:extLst>
+          </p:cNvPr>
+          <p:cNvSpPr txBox="1"/>
+          <p:nvPr/>
+        </p:nvSpPr>
+        <p:spPr>
+          <a:xfrm>
+            <a:off x="8184776" y="1329820"/>
+            <a:ext cx="3188776" cy="553998"/>
+          </a:xfrm>
+          <a:prstGeom prst="rect">
+            <a:avLst/>
+          </a:prstGeom>
+          <a:noFill/>
+        </p:spPr>
+        <p:txBody>
+          <a:bodyPr wrap="square" rtlCol="0">
+            <a:spAutoFit/>
+          </a:bodyPr>
+          <a:lstStyle/>
+          <a:p>
+            <a:r>
+              <a:rPr lang="en-US" sz="1000" dirty="0"/>
+              <a:t>Adjust this screw pot while measuring the voltage on the screw head until #volts = half the #amps for desired current limit (0.75V for 1.5A)</a:t>
+            </a:r>
+          </a:p>
+        </p:txBody>
+      </p:sp>
     </p:spTree>
     <p:extLst>
       <p:ext uri="{BB962C8B-B14F-4D97-AF65-F5344CB8AC3E}">
@@ -2549,7 +3623,7 @@
             <p:ph idx="1"/>
             <p:extLst>
               <p:ext uri="{D42A27DB-BD31-4B8C-83A1-F6EECF244321}">
-                <p14:modId xmlns:p14="http://schemas.microsoft.com/office/powerpoint/2010/main" val="1880578312"/>
+                <p14:modId xmlns:p14="http://schemas.microsoft.com/office/powerpoint/2010/main" val="642311961"/>
               </p:ext>
             </p:extLst>
           </p:nvPr>
@@ -3074,7 +4148,10 @@
                     <a:bodyPr/>
                     <a:lstStyle/>
                     <a:p>
-                      <a:endParaRPr lang="en-US" sz="1000" dirty="0"/>
+                      <a:r>
+                        <a:rPr lang="en-US" sz="1000" dirty="0"/>
+                        <a:t>22 AWG solid core wire</a:t>
+                      </a:r>
                     </a:p>
                   </a:txBody>
                   <a:tcPr/>
@@ -3094,7 +4171,10 @@
                     <a:bodyPr/>
                     <a:lstStyle/>
                     <a:p>
-                      <a:endParaRPr lang="en-US" sz="1000" dirty="0"/>
+                      <a:r>
+                        <a:rPr lang="en-US" sz="1000" dirty="0"/>
+                        <a:t>On board</a:t>
+                      </a:r>
                     </a:p>
                   </a:txBody>
                   <a:tcPr/>
@@ -3191,7 +4271,7 @@
         <p:spPr>
           <a:xfrm>
             <a:off x="4471793" y="6290758"/>
-            <a:ext cx="7173388" cy="553998"/>
+            <a:ext cx="7173388" cy="400110"/>
           </a:xfrm>
           <a:prstGeom prst="rect">
             <a:avLst/>
@@ -3203,12 +4283,6 @@
             <a:spAutoFit/>
           </a:bodyPr>
           <a:lstStyle/>
-          <a:p>
-            <a:r>
-              <a:rPr lang="en-US" sz="1000" dirty="0"/>
-              <a:t>3D designs copyright 2024 Gryphon A. Drake</a:t>
-            </a:r>
-          </a:p>
           <a:p>
             <a:r>
               <a:rPr lang="en-US" sz="1000" dirty="0"/>
@@ -4004,6 +5078,21 @@
 </file>
 
 <file path=customXml/item1.xml><?xml version="1.0" encoding="utf-8"?>
+<p:properties xmlns:p="http://schemas.microsoft.com/office/2006/metadata/properties" xmlns:xsi="http://www.w3.org/2001/XMLSchema-instance" xmlns:pc="http://schemas.microsoft.com/office/infopath/2007/PartnerControls">
+  <documentManagement/>
+</p:properties>
+</file>
+
+<file path=customXml/item2.xml><?xml version="1.0" encoding="utf-8"?>
+<?mso-contentType ?>
+<FormTemplates xmlns="http://schemas.microsoft.com/sharepoint/v3/contenttype/forms">
+  <Display>DocumentLibraryForm</Display>
+  <Edit>DocumentLibraryForm</Edit>
+  <New>DocumentLibraryForm</New>
+</FormTemplates>
+</file>
+
+<file path=customXml/item3.xml><?xml version="1.0" encoding="utf-8"?>
 <ct:contentTypeSchema xmlns:ct="http://schemas.microsoft.com/office/2006/metadata/contentType" xmlns:ma="http://schemas.microsoft.com/office/2006/metadata/properties/metaAttributes" ct:_="" ma:_="" ma:contentTypeName="Document" ma:contentTypeID="0x010100AEECEE844703BA4190C49DA8BC829728" ma:contentTypeVersion="4" ma:contentTypeDescription="Create a new document." ma:contentTypeScope="" ma:versionID="da633761d8a18fa779bcda5bc79afac4">
   <xsd:schema xmlns:xsd="http://www.w3.org/2001/XMLSchema" xmlns:xs="http://www.w3.org/2001/XMLSchema" xmlns:p="http://schemas.microsoft.com/office/2006/metadata/properties" xmlns:ns3="2bd4e6e1-2c8d-49cd-9bbc-672eee709708" targetNamespace="http://schemas.microsoft.com/office/2006/metadata/properties" ma:root="true" ma:fieldsID="536f4b1386eee13875ad531dd634fe92" ns3:_="">
     <xsd:import namespace="2bd4e6e1-2c8d-49cd-9bbc-672eee709708"/>
@@ -4149,22 +5238,31 @@
 </ct:contentTypeSchema>
 </file>
 
-<file path=customXml/item2.xml><?xml version="1.0" encoding="utf-8"?>
-<?mso-contentType ?>
-<FormTemplates xmlns="http://schemas.microsoft.com/sharepoint/v3/contenttype/forms">
-  <Display>DocumentLibraryForm</Display>
-  <Edit>DocumentLibraryForm</Edit>
-  <New>DocumentLibraryForm</New>
-</FormTemplates>
+<file path=customXml/itemProps1.xml><?xml version="1.0" encoding="utf-8"?>
+<ds:datastoreItem xmlns:ds="http://schemas.openxmlformats.org/officeDocument/2006/customXml" ds:itemID="{70DF747F-86F1-4A20-AE37-438D55E3287B}">
+  <ds:schemaRefs>
+    <ds:schemaRef ds:uri="http://schemas.microsoft.com/office/2006/documentManagement/types"/>
+    <ds:schemaRef ds:uri="http://purl.org/dc/elements/1.1/"/>
+    <ds:schemaRef ds:uri="http://schemas.openxmlformats.org/package/2006/metadata/core-properties"/>
+    <ds:schemaRef ds:uri="http://schemas.microsoft.com/office/2006/metadata/properties"/>
+    <ds:schemaRef ds:uri="http://www.w3.org/XML/1998/namespace"/>
+    <ds:schemaRef ds:uri="http://purl.org/dc/terms/"/>
+    <ds:schemaRef ds:uri="http://schemas.microsoft.com/office/infopath/2007/PartnerControls"/>
+    <ds:schemaRef ds:uri="2bd4e6e1-2c8d-49cd-9bbc-672eee709708"/>
+    <ds:schemaRef ds:uri="http://purl.org/dc/dcmitype/"/>
+  </ds:schemaRefs>
+</ds:datastoreItem>
 </file>
 
-<file path=customXml/item3.xml><?xml version="1.0" encoding="utf-8"?>
-<p:properties xmlns:p="http://schemas.microsoft.com/office/2006/metadata/properties" xmlns:xsi="http://www.w3.org/2001/XMLSchema-instance" xmlns:pc="http://schemas.microsoft.com/office/infopath/2007/PartnerControls">
-  <documentManagement/>
-</p:properties>
+<file path=customXml/itemProps2.xml><?xml version="1.0" encoding="utf-8"?>
+<ds:datastoreItem xmlns:ds="http://schemas.openxmlformats.org/officeDocument/2006/customXml" ds:itemID="{D20E565E-B67D-4279-ADB5-47ED6CE6BF60}">
+  <ds:schemaRefs>
+    <ds:schemaRef ds:uri="http://schemas.microsoft.com/sharepoint/v3/contenttype/forms"/>
+  </ds:schemaRefs>
+</ds:datastoreItem>
 </file>
 
-<file path=customXml/itemProps1.xml><?xml version="1.0" encoding="utf-8"?>
+<file path=customXml/itemProps3.xml><?xml version="1.0" encoding="utf-8"?>
 <ds:datastoreItem xmlns:ds="http://schemas.openxmlformats.org/officeDocument/2006/customXml" ds:itemID="{341B2891-B75C-4240-B385-255435C39FC2}">
   <ds:schemaRefs>
     <ds:schemaRef ds:uri="http://schemas.microsoft.com/office/2006/metadata/contentType"/>
@@ -4180,28 +5278,4 @@
     <ds:schemaRef ds:uri="http://schemas.microsoft.com/internal/obd"/>
   </ds:schemaRefs>
 </ds:datastoreItem>
-</file>
-
-<file path=customXml/itemProps2.xml><?xml version="1.0" encoding="utf-8"?>
-<ds:datastoreItem xmlns:ds="http://schemas.openxmlformats.org/officeDocument/2006/customXml" ds:itemID="{D20E565E-B67D-4279-ADB5-47ED6CE6BF60}">
-  <ds:schemaRefs>
-    <ds:schemaRef ds:uri="http://schemas.microsoft.com/sharepoint/v3/contenttype/forms"/>
-  </ds:schemaRefs>
-</ds:datastoreItem>
-</file>
-
-<file path=customXml/itemProps3.xml><?xml version="1.0" encoding="utf-8"?>
-<ds:datastoreItem xmlns:ds="http://schemas.openxmlformats.org/officeDocument/2006/customXml" ds:itemID="{70DF747F-86F1-4A20-AE37-438D55E3287B}">
-  <ds:schemaRefs>
-    <ds:schemaRef ds:uri="http://purl.org/dc/elements/1.1/"/>
-    <ds:schemaRef ds:uri="http://schemas.microsoft.com/office/2006/metadata/properties"/>
-    <ds:schemaRef ds:uri="http://purl.org/dc/terms/"/>
-    <ds:schemaRef ds:uri="http://schemas.openxmlformats.org/package/2006/metadata/core-properties"/>
-    <ds:schemaRef ds:uri="2bd4e6e1-2c8d-49cd-9bbc-672eee709708"/>
-    <ds:schemaRef ds:uri="http://schemas.microsoft.com/office/2006/documentManagement/types"/>
-    <ds:schemaRef ds:uri="http://schemas.microsoft.com/office/infopath/2007/PartnerControls"/>
-    <ds:schemaRef ds:uri="http://www.w3.org/XML/1998/namespace"/>
-    <ds:schemaRef ds:uri="http://purl.org/dc/dcmitype/"/>
-  </ds:schemaRefs>
-</ds:datastoreItem>
 </file>
</xml_diff>